<commit_message>
Add presentation deck update and UI mockups
</commit_message>
<xml_diff>
--- a/presentation/HSDES_NEXUS_Presentation.pptx
+++ b/presentation/HSDES_NEXUS_Presentation.pptx
@@ -5,14 +5,14 @@
     <p:sldMasterId id="2147483648" r:id="rId1"/>
   </p:sldMasterIdLst>
   <p:sldIdLst>
-    <p:sldId id="256" r:id="rId7"/>
-    <p:sldId id="257" r:id="rId8"/>
-    <p:sldId id="258" r:id="rId9"/>
-    <p:sldId id="259" r:id="rId10"/>
-    <p:sldId id="260" r:id="rId11"/>
-    <p:sldId id="261" r:id="rId12"/>
+    <p:sldId id="256" r:id="rId2"/>
+    <p:sldId id="257" r:id="rId3"/>
+    <p:sldId id="258" r:id="rId4"/>
+    <p:sldId id="259" r:id="rId5"/>
+    <p:sldId id="260" r:id="rId6"/>
+    <p:sldId id="261" r:id="rId7"/>
   </p:sldIdLst>
-  <p:sldSz cx="12191695" cy="6858000" type="screen4x3"/>
+  <p:sldSz cx="12192000" cy="6858000"/>
   <p:notesSz cx="6858000" cy="9144000"/>
   <p:defaultTextStyle>
     <a:defPPr>
@@ -109,7 +109,52 @@
       </a:defRPr>
     </a:lvl9pPr>
   </p:defaultTextStyle>
+  <p:extLst>
+    <p:ext uri="{EFAFB233-063F-42B5-8137-9DF3F51BA10A}">
+      <p15:sldGuideLst xmlns:p15="http://schemas.microsoft.com/office/powerpoint/2012/main">
+        <p15:guide id="1" orient="horz" pos="2160">
+          <p15:clr>
+            <a:srgbClr val="A4A3A4"/>
+          </p15:clr>
+        </p15:guide>
+        <p15:guide id="2" pos="2880">
+          <p15:clr>
+            <a:srgbClr val="A4A3A4"/>
+          </p15:clr>
+        </p15:guide>
+      </p15:sldGuideLst>
+    </p:ext>
+  </p:extLst>
 </p:presentation>
+</file>
+
+<file path=ppt/changesInfos/changesInfo1.xml><?xml version="1.0" encoding="utf-8"?>
+<pc:chgInfo xmlns:a="http://schemas.openxmlformats.org/drawingml/2006/main" xmlns:r="http://schemas.openxmlformats.org/officeDocument/2006/relationships" xmlns:ac="http://schemas.microsoft.com/office/drawing/2013/main/command" xmlns:pc="http://schemas.microsoft.com/office/powerpoint/2013/main/command">
+  <pc:docChgLst>
+    <pc:chgData name="Rajaram, Balaji" userId="ef3de614-10a3-4ba9-80dc-e89bcc86f5f4" providerId="ADAL" clId="{7C535360-BD65-42DA-BD95-1E44F351206F}"/>
+    <pc:docChg chg="undo custSel modSld">
+      <pc:chgData name="Rajaram, Balaji" userId="ef3de614-10a3-4ba9-80dc-e89bcc86f5f4" providerId="ADAL" clId="{7C535360-BD65-42DA-BD95-1E44F351206F}" dt="2026-09-02T06:31:51" v="1" actId="1076"/>
+      <pc:docMkLst>
+        <pc:docMk/>
+      </pc:docMkLst>
+      <pc:sldChg chg="modSp mod">
+        <pc:chgData name="Rajaram, Balaji" userId="ef3de614-10a3-4ba9-80dc-e89bcc86f5f4" providerId="ADAL" clId="{7C535360-BD65-42DA-BD95-1E44F351206F}" dt="2026-09-02T06:31:51" v="1" actId="1076"/>
+        <pc:sldMkLst>
+          <pc:docMk/>
+          <pc:sldMk cId="0" sldId="261"/>
+        </pc:sldMkLst>
+        <pc:spChg chg="mod">
+          <ac:chgData name="Rajaram, Balaji" userId="ef3de614-10a3-4ba9-80dc-e89bcc86f5f4" providerId="ADAL" clId="{7C535360-BD65-42DA-BD95-1E44F351206F}" dt="2026-09-02T06:31:51" v="1" actId="1076"/>
+          <ac:spMkLst>
+            <pc:docMk/>
+            <pc:sldMk cId="0" sldId="261"/>
+            <ac:spMk id="3" creationId="{00000000-0000-0000-0000-000000000000}"/>
+          </ac:spMkLst>
+        </pc:spChg>
+      </pc:sldChg>
+    </pc:docChg>
+  </pc:docChgLst>
+</pc:chgInfo>
 </file>
 
 <file path=ppt/slideLayouts/slideLayout1.xml><?xml version="1.0" encoding="utf-8"?>
@@ -150,10 +195,9 @@
           <a:lstStyle/>
           <a:p>
             <a:r>
-              <a:rPr lang="en-US" smtClean="0"/>
+              <a:rPr lang="en-US"/>
               <a:t>Click to edit Master title style</a:t>
             </a:r>
-            <a:endParaRPr lang="en-US"/>
           </a:p>
         </p:txBody>
       </p:sp>
@@ -269,10 +313,9 @@
           </a:lstStyle>
           <a:p>
             <a:r>
-              <a:rPr lang="en-US" smtClean="0"/>
+              <a:rPr lang="en-US"/>
               <a:t>Click to edit Master subtitle style</a:t>
             </a:r>
-            <a:endParaRPr lang="en-US"/>
           </a:p>
         </p:txBody>
       </p:sp>
@@ -293,7 +336,7 @@
           <a:p>
             <a:fld id="{5BCAD085-E8A6-8845-BD4E-CB4CCA059FC4}" type="datetimeFigureOut">
               <a:rPr lang="en-US" smtClean="0"/>
-              <a:t>1/27/13</a:t>
+              <a:t>9/2/2026</a:t>
             </a:fld>
             <a:endParaRPr lang="en-US"/>
           </a:p>
@@ -387,10 +430,9 @@
           <a:lstStyle/>
           <a:p>
             <a:r>
-              <a:rPr lang="en-US" smtClean="0"/>
+              <a:rPr lang="en-US"/>
               <a:t>Click to edit Master title style</a:t>
             </a:r>
-            <a:endParaRPr lang="en-US"/>
           </a:p>
         </p:txBody>
       </p:sp>
@@ -411,38 +453,37 @@
           <a:p>
             <a:pPr lvl="0"/>
             <a:r>
-              <a:rPr lang="en-US" smtClean="0"/>
+              <a:rPr lang="en-US"/>
               <a:t>Click to edit Master text styles</a:t>
             </a:r>
           </a:p>
           <a:p>
             <a:pPr lvl="1"/>
             <a:r>
-              <a:rPr lang="en-US" smtClean="0"/>
+              <a:rPr lang="en-US"/>
               <a:t>Second level</a:t>
             </a:r>
           </a:p>
           <a:p>
             <a:pPr lvl="2"/>
             <a:r>
-              <a:rPr lang="en-US" smtClean="0"/>
+              <a:rPr lang="en-US"/>
               <a:t>Third level</a:t>
             </a:r>
           </a:p>
           <a:p>
             <a:pPr lvl="3"/>
             <a:r>
-              <a:rPr lang="en-US" smtClean="0"/>
+              <a:rPr lang="en-US"/>
               <a:t>Fourth level</a:t>
             </a:r>
           </a:p>
           <a:p>
             <a:pPr lvl="4"/>
             <a:r>
-              <a:rPr lang="en-US" smtClean="0"/>
+              <a:rPr lang="en-US"/>
               <a:t>Fifth level</a:t>
             </a:r>
-            <a:endParaRPr lang="en-US"/>
           </a:p>
         </p:txBody>
       </p:sp>
@@ -463,7 +504,7 @@
           <a:p>
             <a:fld id="{5BCAD085-E8A6-8845-BD4E-CB4CCA059FC4}" type="datetimeFigureOut">
               <a:rPr lang="en-US" smtClean="0"/>
-              <a:t>1/27/13</a:t>
+              <a:t>9/2/2026</a:t>
             </a:fld>
             <a:endParaRPr lang="en-US"/>
           </a:p>
@@ -562,10 +603,9 @@
           <a:lstStyle/>
           <a:p>
             <a:r>
-              <a:rPr lang="en-US" smtClean="0"/>
+              <a:rPr lang="en-US"/>
               <a:t>Click to edit Master title style</a:t>
             </a:r>
-            <a:endParaRPr lang="en-US"/>
           </a:p>
         </p:txBody>
       </p:sp>
@@ -591,38 +631,37 @@
           <a:p>
             <a:pPr lvl="0"/>
             <a:r>
-              <a:rPr lang="en-US" smtClean="0"/>
+              <a:rPr lang="en-US"/>
               <a:t>Click to edit Master text styles</a:t>
             </a:r>
           </a:p>
           <a:p>
             <a:pPr lvl="1"/>
             <a:r>
-              <a:rPr lang="en-US" smtClean="0"/>
+              <a:rPr lang="en-US"/>
               <a:t>Second level</a:t>
             </a:r>
           </a:p>
           <a:p>
             <a:pPr lvl="2"/>
             <a:r>
-              <a:rPr lang="en-US" smtClean="0"/>
+              <a:rPr lang="en-US"/>
               <a:t>Third level</a:t>
             </a:r>
           </a:p>
           <a:p>
             <a:pPr lvl="3"/>
             <a:r>
-              <a:rPr lang="en-US" smtClean="0"/>
+              <a:rPr lang="en-US"/>
               <a:t>Fourth level</a:t>
             </a:r>
           </a:p>
           <a:p>
             <a:pPr lvl="4"/>
             <a:r>
-              <a:rPr lang="en-US" smtClean="0"/>
+              <a:rPr lang="en-US"/>
               <a:t>Fifth level</a:t>
             </a:r>
-            <a:endParaRPr lang="en-US"/>
           </a:p>
         </p:txBody>
       </p:sp>
@@ -643,7 +682,7 @@
           <a:p>
             <a:fld id="{5BCAD085-E8A6-8845-BD4E-CB4CCA059FC4}" type="datetimeFigureOut">
               <a:rPr lang="en-US" smtClean="0"/>
-              <a:t>1/27/13</a:t>
+              <a:t>9/2/2026</a:t>
             </a:fld>
             <a:endParaRPr lang="en-US"/>
           </a:p>
@@ -737,10 +776,9 @@
           <a:lstStyle/>
           <a:p>
             <a:r>
-              <a:rPr lang="en-US" smtClean="0"/>
+              <a:rPr lang="en-US"/>
               <a:t>Click to edit Master title style</a:t>
             </a:r>
-            <a:endParaRPr lang="en-US"/>
           </a:p>
         </p:txBody>
       </p:sp>
@@ -761,38 +799,37 @@
           <a:p>
             <a:pPr lvl="0"/>
             <a:r>
-              <a:rPr lang="en-US" smtClean="0"/>
+              <a:rPr lang="en-US"/>
               <a:t>Click to edit Master text styles</a:t>
             </a:r>
           </a:p>
           <a:p>
             <a:pPr lvl="1"/>
             <a:r>
-              <a:rPr lang="en-US" smtClean="0"/>
+              <a:rPr lang="en-US"/>
               <a:t>Second level</a:t>
             </a:r>
           </a:p>
           <a:p>
             <a:pPr lvl="2"/>
             <a:r>
-              <a:rPr lang="en-US" smtClean="0"/>
+              <a:rPr lang="en-US"/>
               <a:t>Third level</a:t>
             </a:r>
           </a:p>
           <a:p>
             <a:pPr lvl="3"/>
             <a:r>
-              <a:rPr lang="en-US" smtClean="0"/>
+              <a:rPr lang="en-US"/>
               <a:t>Fourth level</a:t>
             </a:r>
           </a:p>
           <a:p>
             <a:pPr lvl="4"/>
             <a:r>
-              <a:rPr lang="en-US" smtClean="0"/>
+              <a:rPr lang="en-US"/>
               <a:t>Fifth level</a:t>
             </a:r>
-            <a:endParaRPr lang="en-US"/>
           </a:p>
         </p:txBody>
       </p:sp>
@@ -813,7 +850,7 @@
           <a:p>
             <a:fld id="{5BCAD085-E8A6-8845-BD4E-CB4CCA059FC4}" type="datetimeFigureOut">
               <a:rPr lang="en-US" smtClean="0"/>
-              <a:t>1/27/13</a:t>
+              <a:t>9/2/2026</a:t>
             </a:fld>
             <a:endParaRPr lang="en-US"/>
           </a:p>
@@ -916,10 +953,9 @@
           </a:lstStyle>
           <a:p>
             <a:r>
-              <a:rPr lang="en-US" smtClean="0"/>
+              <a:rPr lang="en-US"/>
               <a:t>Click to edit Master title style</a:t>
             </a:r>
-            <a:endParaRPr lang="en-US"/>
           </a:p>
         </p:txBody>
       </p:sp>
@@ -1036,7 +1072,7 @@
           <a:p>
             <a:pPr lvl="0"/>
             <a:r>
-              <a:rPr lang="en-US" smtClean="0"/>
+              <a:rPr lang="en-US"/>
               <a:t>Click to edit Master text styles</a:t>
             </a:r>
           </a:p>
@@ -1059,7 +1095,7 @@
           <a:p>
             <a:fld id="{5BCAD085-E8A6-8845-BD4E-CB4CCA059FC4}" type="datetimeFigureOut">
               <a:rPr lang="en-US" smtClean="0"/>
-              <a:t>1/27/13</a:t>
+              <a:t>9/2/2026</a:t>
             </a:fld>
             <a:endParaRPr lang="en-US"/>
           </a:p>
@@ -1153,10 +1189,9 @@
           <a:lstStyle/>
           <a:p>
             <a:r>
-              <a:rPr lang="en-US" smtClean="0"/>
+              <a:rPr lang="en-US"/>
               <a:t>Click to edit Master title style</a:t>
             </a:r>
-            <a:endParaRPr lang="en-US"/>
           </a:p>
         </p:txBody>
       </p:sp>
@@ -1210,38 +1245,37 @@
           <a:p>
             <a:pPr lvl="0"/>
             <a:r>
-              <a:rPr lang="en-US" smtClean="0"/>
+              <a:rPr lang="en-US"/>
               <a:t>Click to edit Master text styles</a:t>
             </a:r>
           </a:p>
           <a:p>
             <a:pPr lvl="1"/>
             <a:r>
-              <a:rPr lang="en-US" smtClean="0"/>
+              <a:rPr lang="en-US"/>
               <a:t>Second level</a:t>
             </a:r>
           </a:p>
           <a:p>
             <a:pPr lvl="2"/>
             <a:r>
-              <a:rPr lang="en-US" smtClean="0"/>
+              <a:rPr lang="en-US"/>
               <a:t>Third level</a:t>
             </a:r>
           </a:p>
           <a:p>
             <a:pPr lvl="3"/>
             <a:r>
-              <a:rPr lang="en-US" smtClean="0"/>
+              <a:rPr lang="en-US"/>
               <a:t>Fourth level</a:t>
             </a:r>
           </a:p>
           <a:p>
             <a:pPr lvl="4"/>
             <a:r>
-              <a:rPr lang="en-US" smtClean="0"/>
+              <a:rPr lang="en-US"/>
               <a:t>Fifth level</a:t>
             </a:r>
-            <a:endParaRPr lang="en-US"/>
           </a:p>
         </p:txBody>
       </p:sp>
@@ -1295,38 +1329,37 @@
           <a:p>
             <a:pPr lvl="0"/>
             <a:r>
-              <a:rPr lang="en-US" smtClean="0"/>
+              <a:rPr lang="en-US"/>
               <a:t>Click to edit Master text styles</a:t>
             </a:r>
           </a:p>
           <a:p>
             <a:pPr lvl="1"/>
             <a:r>
-              <a:rPr lang="en-US" smtClean="0"/>
+              <a:rPr lang="en-US"/>
               <a:t>Second level</a:t>
             </a:r>
           </a:p>
           <a:p>
             <a:pPr lvl="2"/>
             <a:r>
-              <a:rPr lang="en-US" smtClean="0"/>
+              <a:rPr lang="en-US"/>
               <a:t>Third level</a:t>
             </a:r>
           </a:p>
           <a:p>
             <a:pPr lvl="3"/>
             <a:r>
-              <a:rPr lang="en-US" smtClean="0"/>
+              <a:rPr lang="en-US"/>
               <a:t>Fourth level</a:t>
             </a:r>
           </a:p>
           <a:p>
             <a:pPr lvl="4"/>
             <a:r>
-              <a:rPr lang="en-US" smtClean="0"/>
+              <a:rPr lang="en-US"/>
               <a:t>Fifth level</a:t>
             </a:r>
-            <a:endParaRPr lang="en-US"/>
           </a:p>
         </p:txBody>
       </p:sp>
@@ -1347,7 +1380,7 @@
           <a:p>
             <a:fld id="{5BCAD085-E8A6-8845-BD4E-CB4CCA059FC4}" type="datetimeFigureOut">
               <a:rPr lang="en-US" smtClean="0"/>
-              <a:t>1/27/13</a:t>
+              <a:t>9/2/2026</a:t>
             </a:fld>
             <a:endParaRPr lang="en-US"/>
           </a:p>
@@ -1445,10 +1478,9 @@
           </a:lstStyle>
           <a:p>
             <a:r>
-              <a:rPr lang="en-US" smtClean="0"/>
+              <a:rPr lang="en-US"/>
               <a:t>Click to edit Master title style</a:t>
             </a:r>
-            <a:endParaRPr lang="en-US"/>
           </a:p>
         </p:txBody>
       </p:sp>
@@ -1511,7 +1543,7 @@
           <a:p>
             <a:pPr lvl="0"/>
             <a:r>
-              <a:rPr lang="en-US" smtClean="0"/>
+              <a:rPr lang="en-US"/>
               <a:t>Click to edit Master text styles</a:t>
             </a:r>
           </a:p>
@@ -1567,38 +1599,37 @@
           <a:p>
             <a:pPr lvl="0"/>
             <a:r>
-              <a:rPr lang="en-US" smtClean="0"/>
+              <a:rPr lang="en-US"/>
               <a:t>Click to edit Master text styles</a:t>
             </a:r>
           </a:p>
           <a:p>
             <a:pPr lvl="1"/>
             <a:r>
-              <a:rPr lang="en-US" smtClean="0"/>
+              <a:rPr lang="en-US"/>
               <a:t>Second level</a:t>
             </a:r>
           </a:p>
           <a:p>
             <a:pPr lvl="2"/>
             <a:r>
-              <a:rPr lang="en-US" smtClean="0"/>
+              <a:rPr lang="en-US"/>
               <a:t>Third level</a:t>
             </a:r>
           </a:p>
           <a:p>
             <a:pPr lvl="3"/>
             <a:r>
-              <a:rPr lang="en-US" smtClean="0"/>
+              <a:rPr lang="en-US"/>
               <a:t>Fourth level</a:t>
             </a:r>
           </a:p>
           <a:p>
             <a:pPr lvl="4"/>
             <a:r>
-              <a:rPr lang="en-US" smtClean="0"/>
+              <a:rPr lang="en-US"/>
               <a:t>Fifth level</a:t>
             </a:r>
-            <a:endParaRPr lang="en-US"/>
           </a:p>
         </p:txBody>
       </p:sp>
@@ -1661,7 +1692,7 @@
           <a:p>
             <a:pPr lvl="0"/>
             <a:r>
-              <a:rPr lang="en-US" smtClean="0"/>
+              <a:rPr lang="en-US"/>
               <a:t>Click to edit Master text styles</a:t>
             </a:r>
           </a:p>
@@ -1717,38 +1748,37 @@
           <a:p>
             <a:pPr lvl="0"/>
             <a:r>
-              <a:rPr lang="en-US" smtClean="0"/>
+              <a:rPr lang="en-US"/>
               <a:t>Click to edit Master text styles</a:t>
             </a:r>
           </a:p>
           <a:p>
             <a:pPr lvl="1"/>
             <a:r>
-              <a:rPr lang="en-US" smtClean="0"/>
+              <a:rPr lang="en-US"/>
               <a:t>Second level</a:t>
             </a:r>
           </a:p>
           <a:p>
             <a:pPr lvl="2"/>
             <a:r>
-              <a:rPr lang="en-US" smtClean="0"/>
+              <a:rPr lang="en-US"/>
               <a:t>Third level</a:t>
             </a:r>
           </a:p>
           <a:p>
             <a:pPr lvl="3"/>
             <a:r>
-              <a:rPr lang="en-US" smtClean="0"/>
+              <a:rPr lang="en-US"/>
               <a:t>Fourth level</a:t>
             </a:r>
           </a:p>
           <a:p>
             <a:pPr lvl="4"/>
             <a:r>
-              <a:rPr lang="en-US" smtClean="0"/>
+              <a:rPr lang="en-US"/>
               <a:t>Fifth level</a:t>
             </a:r>
-            <a:endParaRPr lang="en-US"/>
           </a:p>
         </p:txBody>
       </p:sp>
@@ -1769,7 +1799,7 @@
           <a:p>
             <a:fld id="{5BCAD085-E8A6-8845-BD4E-CB4CCA059FC4}" type="datetimeFigureOut">
               <a:rPr lang="en-US" smtClean="0"/>
-              <a:t>1/27/13</a:t>
+              <a:t>9/2/2026</a:t>
             </a:fld>
             <a:endParaRPr lang="en-US"/>
           </a:p>
@@ -1863,10 +1893,9 @@
           <a:lstStyle/>
           <a:p>
             <a:r>
-              <a:rPr lang="en-US" smtClean="0"/>
+              <a:rPr lang="en-US"/>
               <a:t>Click to edit Master title style</a:t>
             </a:r>
-            <a:endParaRPr lang="en-US"/>
           </a:p>
         </p:txBody>
       </p:sp>
@@ -1887,7 +1916,7 @@
           <a:p>
             <a:fld id="{5BCAD085-E8A6-8845-BD4E-CB4CCA059FC4}" type="datetimeFigureOut">
               <a:rPr lang="en-US" smtClean="0"/>
-              <a:t>1/27/13</a:t>
+              <a:t>9/2/2026</a:t>
             </a:fld>
             <a:endParaRPr lang="en-US"/>
           </a:p>
@@ -1982,7 +2011,7 @@
           <a:p>
             <a:fld id="{5BCAD085-E8A6-8845-BD4E-CB4CCA059FC4}" type="datetimeFigureOut">
               <a:rPr lang="en-US" smtClean="0"/>
-              <a:t>1/27/13</a:t>
+              <a:t>9/2/2026</a:t>
             </a:fld>
             <a:endParaRPr lang="en-US"/>
           </a:p>
@@ -2085,10 +2114,9 @@
           </a:lstStyle>
           <a:p>
             <a:r>
-              <a:rPr lang="en-US" smtClean="0"/>
+              <a:rPr lang="en-US"/>
               <a:t>Click to edit Master title style</a:t>
             </a:r>
-            <a:endParaRPr lang="en-US"/>
           </a:p>
         </p:txBody>
       </p:sp>
@@ -2142,38 +2170,37 @@
           <a:p>
             <a:pPr lvl="0"/>
             <a:r>
-              <a:rPr lang="en-US" smtClean="0"/>
+              <a:rPr lang="en-US"/>
               <a:t>Click to edit Master text styles</a:t>
             </a:r>
           </a:p>
           <a:p>
             <a:pPr lvl="1"/>
             <a:r>
-              <a:rPr lang="en-US" smtClean="0"/>
+              <a:rPr lang="en-US"/>
               <a:t>Second level</a:t>
             </a:r>
           </a:p>
           <a:p>
             <a:pPr lvl="2"/>
             <a:r>
-              <a:rPr lang="en-US" smtClean="0"/>
+              <a:rPr lang="en-US"/>
               <a:t>Third level</a:t>
             </a:r>
           </a:p>
           <a:p>
             <a:pPr lvl="3"/>
             <a:r>
-              <a:rPr lang="en-US" smtClean="0"/>
+              <a:rPr lang="en-US"/>
               <a:t>Fourth level</a:t>
             </a:r>
           </a:p>
           <a:p>
             <a:pPr lvl="4"/>
             <a:r>
-              <a:rPr lang="en-US" smtClean="0"/>
+              <a:rPr lang="en-US"/>
               <a:t>Fifth level</a:t>
             </a:r>
-            <a:endParaRPr lang="en-US"/>
           </a:p>
         </p:txBody>
       </p:sp>
@@ -2236,7 +2263,7 @@
           <a:p>
             <a:pPr lvl="0"/>
             <a:r>
-              <a:rPr lang="en-US" smtClean="0"/>
+              <a:rPr lang="en-US"/>
               <a:t>Click to edit Master text styles</a:t>
             </a:r>
           </a:p>
@@ -2259,7 +2286,7 @@
           <a:p>
             <a:fld id="{5BCAD085-E8A6-8845-BD4E-CB4CCA059FC4}" type="datetimeFigureOut">
               <a:rPr lang="en-US" smtClean="0"/>
-              <a:t>1/27/13</a:t>
+              <a:t>9/2/2026</a:t>
             </a:fld>
             <a:endParaRPr lang="en-US"/>
           </a:p>
@@ -2362,10 +2389,9 @@
           </a:lstStyle>
           <a:p>
             <a:r>
-              <a:rPr lang="en-US" smtClean="0"/>
+              <a:rPr lang="en-US"/>
               <a:t>Click to edit Master title style</a:t>
             </a:r>
-            <a:endParaRPr lang="en-US"/>
           </a:p>
         </p:txBody>
       </p:sp>
@@ -2489,7 +2515,7 @@
           <a:p>
             <a:pPr lvl="0"/>
             <a:r>
-              <a:rPr lang="en-US" smtClean="0"/>
+              <a:rPr lang="en-US"/>
               <a:t>Click to edit Master text styles</a:t>
             </a:r>
           </a:p>
@@ -2512,7 +2538,7 @@
           <a:p>
             <a:fld id="{5BCAD085-E8A6-8845-BD4E-CB4CCA059FC4}" type="datetimeFigureOut">
               <a:rPr lang="en-US" smtClean="0"/>
-              <a:t>1/27/13</a:t>
+              <a:t>9/2/2026</a:t>
             </a:fld>
             <a:endParaRPr lang="en-US"/>
           </a:p>
@@ -2621,10 +2647,9 @@
           <a:lstStyle/>
           <a:p>
             <a:r>
-              <a:rPr lang="en-US" smtClean="0"/>
+              <a:rPr lang="en-US"/>
               <a:t>Click to edit Master title style</a:t>
             </a:r>
-            <a:endParaRPr lang="en-US"/>
           </a:p>
         </p:txBody>
       </p:sp>
@@ -2655,38 +2680,37 @@
           <a:p>
             <a:pPr lvl="0"/>
             <a:r>
-              <a:rPr lang="en-US" smtClean="0"/>
+              <a:rPr lang="en-US"/>
               <a:t>Click to edit Master text styles</a:t>
             </a:r>
           </a:p>
           <a:p>
             <a:pPr lvl="1"/>
             <a:r>
-              <a:rPr lang="en-US" smtClean="0"/>
+              <a:rPr lang="en-US"/>
               <a:t>Second level</a:t>
             </a:r>
           </a:p>
           <a:p>
             <a:pPr lvl="2"/>
             <a:r>
-              <a:rPr lang="en-US" smtClean="0"/>
+              <a:rPr lang="en-US"/>
               <a:t>Third level</a:t>
             </a:r>
           </a:p>
           <a:p>
             <a:pPr lvl="3"/>
             <a:r>
-              <a:rPr lang="en-US" smtClean="0"/>
+              <a:rPr lang="en-US"/>
               <a:t>Fourth level</a:t>
             </a:r>
           </a:p>
           <a:p>
             <a:pPr lvl="4"/>
             <a:r>
-              <a:rPr lang="en-US" smtClean="0"/>
+              <a:rPr lang="en-US"/>
               <a:t>Fifth level</a:t>
             </a:r>
-            <a:endParaRPr lang="en-US"/>
           </a:p>
         </p:txBody>
       </p:sp>
@@ -2725,7 +2749,7 @@
           <a:p>
             <a:fld id="{5BCAD085-E8A6-8845-BD4E-CB4CCA059FC4}" type="datetimeFigureOut">
               <a:rPr lang="en-US" smtClean="0"/>
-              <a:t>1/27/13</a:t>
+              <a:t>9/2/2026</a:t>
             </a:fld>
             <a:endParaRPr lang="en-US"/>
           </a:p>
@@ -3084,7 +3108,7 @@
 </file>
 
 <file path=ppt/slides/slide1.xml><?xml version="1.0" encoding="utf-8"?>
-<p:sld xmlns:a="http://schemas.openxmlformats.org/drawingml/2006/main" xmlns:p="http://schemas.openxmlformats.org/presentationml/2006/main" xmlns:r="http://schemas.openxmlformats.org/officeDocument/2006/relationships">
+<p:sld xmlns:a="http://schemas.openxmlformats.org/drawingml/2006/main" xmlns:r="http://schemas.openxmlformats.org/officeDocument/2006/relationships" xmlns:p="http://schemas.openxmlformats.org/presentationml/2006/main">
   <p:cSld>
     <p:spTree>
       <p:nvGrpSpPr>
@@ -3092,7 +3116,14 @@
         <p:cNvGrpSpPr/>
         <p:nvPr/>
       </p:nvGrpSpPr>
-      <p:grpSpPr/>
+      <p:grpSpPr>
+        <a:xfrm>
+          <a:off x="0" y="0"/>
+          <a:ext cx="0" cy="0"/>
+          <a:chOff x="0" y="0"/>
+          <a:chExt cx="0" cy="0"/>
+        </a:xfrm>
+      </p:grpSpPr>
       <p:sp>
         <p:nvSpPr>
           <p:cNvPr id="2" name="Rectangle 1"/>
@@ -3133,6 +3164,7 @@
           <a:lstStyle/>
           <a:p>
             <a:pPr algn="ctr"/>
+            <a:endParaRPr/>
           </a:p>
         </p:txBody>
       </p:sp>
@@ -3166,6 +3198,7 @@
               </a:defRPr>
             </a:pPr>
             <a:r>
+              <a:rPr dirty="0"/>
               <a:t>HSDES NEXUS</a:t>
             </a:r>
           </a:p>
@@ -3178,7 +3211,16 @@
               </a:defRPr>
             </a:pPr>
             <a:r>
-              <a:t>Agentic HSD Triage  +  PythonSV Live Debug over the Lab NUC</a:t>
+              <a:rPr dirty="0"/>
+              <a:t>Agentic HSD Triage  +  </a:t>
+            </a:r>
+            <a:r>
+              <a:rPr dirty="0" err="1"/>
+              <a:t>PythonSV</a:t>
+            </a:r>
+            <a:r>
+              <a:rPr dirty="0"/>
+              <a:t> Live Debug over the Lab NUC</a:t>
             </a:r>
           </a:p>
           <a:p>
@@ -3190,7 +3232,24 @@
               </a:defRPr>
             </a:pPr>
             <a:r>
-              <a:t>Evolution of BugScout — one FastAPI tool for server-platform debug</a:t>
+              <a:rPr dirty="0"/>
+              <a:t>Evolution of </a:t>
+            </a:r>
+            <a:r>
+              <a:rPr dirty="0" err="1"/>
+              <a:t>BugScout</a:t>
+            </a:r>
+            <a:r>
+              <a:rPr dirty="0"/>
+              <a:t> — one </a:t>
+            </a:r>
+            <a:r>
+              <a:rPr dirty="0" err="1"/>
+              <a:t>FastAPI</a:t>
+            </a:r>
+            <a:r>
+              <a:rPr dirty="0"/>
+              <a:t> tool for server-platform debug</a:t>
             </a:r>
           </a:p>
         </p:txBody>
@@ -3235,6 +3294,7 @@
           <a:lstStyle/>
           <a:p>
             <a:pPr algn="ctr"/>
+            <a:endParaRPr/>
           </a:p>
         </p:txBody>
       </p:sp>
@@ -3247,7 +3307,7 @@
 </file>
 
 <file path=ppt/slides/slide2.xml><?xml version="1.0" encoding="utf-8"?>
-<p:sld xmlns:a="http://schemas.openxmlformats.org/drawingml/2006/main" xmlns:p="http://schemas.openxmlformats.org/presentationml/2006/main" xmlns:r="http://schemas.openxmlformats.org/officeDocument/2006/relationships">
+<p:sld xmlns:a="http://schemas.openxmlformats.org/drawingml/2006/main" xmlns:r="http://schemas.openxmlformats.org/officeDocument/2006/relationships" xmlns:p="http://schemas.openxmlformats.org/presentationml/2006/main">
   <p:cSld>
     <p:spTree>
       <p:nvGrpSpPr>
@@ -3255,7 +3315,14 @@
         <p:cNvGrpSpPr/>
         <p:nvPr/>
       </p:nvGrpSpPr>
-      <p:grpSpPr/>
+      <p:grpSpPr>
+        <a:xfrm>
+          <a:off x="0" y="0"/>
+          <a:ext cx="0" cy="0"/>
+          <a:chOff x="0" y="0"/>
+          <a:chExt cx="0" cy="0"/>
+        </a:xfrm>
+      </p:grpSpPr>
       <p:sp>
         <p:nvSpPr>
           <p:cNvPr id="2" name="Rectangle 1"/>
@@ -3292,7 +3359,7 @@
           </a:fontRef>
         </p:style>
         <p:txBody>
-          <a:bodyPr rtlCol="0" anchor="ctr" lIns="365760" wrap="square"/>
+          <a:bodyPr wrap="square" lIns="365760" rtlCol="0" anchor="ctr"/>
           <a:lstStyle/>
           <a:p>
             <a:pPr algn="ctr">
@@ -3442,7 +3509,7 @@
 </file>
 
 <file path=ppt/slides/slide3.xml><?xml version="1.0" encoding="utf-8"?>
-<p:sld xmlns:a="http://schemas.openxmlformats.org/drawingml/2006/main" xmlns:p="http://schemas.openxmlformats.org/presentationml/2006/main" xmlns:r="http://schemas.openxmlformats.org/officeDocument/2006/relationships">
+<p:sld xmlns:a="http://schemas.openxmlformats.org/drawingml/2006/main" xmlns:r="http://schemas.openxmlformats.org/officeDocument/2006/relationships" xmlns:p="http://schemas.openxmlformats.org/presentationml/2006/main">
   <p:cSld>
     <p:spTree>
       <p:nvGrpSpPr>
@@ -3450,7 +3517,14 @@
         <p:cNvGrpSpPr/>
         <p:nvPr/>
       </p:nvGrpSpPr>
-      <p:grpSpPr/>
+      <p:grpSpPr>
+        <a:xfrm>
+          <a:off x="0" y="0"/>
+          <a:ext cx="0" cy="0"/>
+          <a:chOff x="0" y="0"/>
+          <a:chExt cx="0" cy="0"/>
+        </a:xfrm>
+      </p:grpSpPr>
       <p:sp>
         <p:nvSpPr>
           <p:cNvPr id="2" name="Rectangle 1"/>
@@ -3487,7 +3561,7 @@
           </a:fontRef>
         </p:style>
         <p:txBody>
-          <a:bodyPr rtlCol="0" anchor="ctr" lIns="365760" wrap="square"/>
+          <a:bodyPr wrap="square" lIns="365760" rtlCol="0" anchor="ctr"/>
           <a:lstStyle/>
           <a:p>
             <a:pPr algn="ctr">
@@ -3541,7 +3615,7 @@
           </a:fontRef>
         </p:style>
         <p:txBody>
-          <a:bodyPr rtlCol="0" anchor="ctr" wrap="square"/>
+          <a:bodyPr wrap="square" rtlCol="0" anchor="ctr"/>
           <a:lstStyle/>
           <a:p>
             <a:pPr algn="ctr">
@@ -3595,7 +3669,7 @@
           </a:fontRef>
         </p:style>
         <p:txBody>
-          <a:bodyPr rtlCol="0" anchor="ctr" wrap="square"/>
+          <a:bodyPr wrap="square" rtlCol="0" anchor="ctr"/>
           <a:lstStyle/>
           <a:p>
             <a:pPr algn="ctr">
@@ -3685,7 +3759,7 @@
           </a:fontRef>
         </p:style>
         <p:txBody>
-          <a:bodyPr rtlCol="0" anchor="ctr" wrap="square"/>
+          <a:bodyPr wrap="square" rtlCol="0" anchor="ctr"/>
           <a:lstStyle/>
           <a:p>
             <a:pPr algn="ctr">
@@ -3775,7 +3849,7 @@
           </a:fontRef>
         </p:style>
         <p:txBody>
-          <a:bodyPr rtlCol="0" anchor="ctr" wrap="square"/>
+          <a:bodyPr wrap="square" rtlCol="0" anchor="ctr"/>
           <a:lstStyle/>
           <a:p>
             <a:pPr algn="ctr">
@@ -3865,7 +3939,7 @@
           </a:fontRef>
         </p:style>
         <p:txBody>
-          <a:bodyPr rtlCol="0" anchor="ctr" wrap="square"/>
+          <a:bodyPr wrap="square" rtlCol="0" anchor="ctr"/>
           <a:lstStyle/>
           <a:p>
             <a:pPr algn="ctr">
@@ -3955,7 +4029,7 @@
           </a:fontRef>
         </p:style>
         <p:txBody>
-          <a:bodyPr rtlCol="0" anchor="ctr" wrap="square"/>
+          <a:bodyPr wrap="square" rtlCol="0" anchor="ctr"/>
           <a:lstStyle/>
           <a:p>
             <a:pPr algn="ctr">
@@ -4009,7 +4083,7 @@
           </a:fontRef>
         </p:style>
         <p:txBody>
-          <a:bodyPr rtlCol="0" anchor="ctr" wrap="square"/>
+          <a:bodyPr wrap="square" rtlCol="0" anchor="ctr"/>
           <a:lstStyle/>
           <a:p>
             <a:pPr algn="ctr">
@@ -4063,7 +4137,7 @@
           </a:fontRef>
         </p:style>
         <p:txBody>
-          <a:bodyPr rtlCol="0" anchor="ctr" wrap="square"/>
+          <a:bodyPr wrap="square" rtlCol="0" anchor="ctr"/>
           <a:lstStyle/>
           <a:p>
             <a:pPr algn="ctr">
@@ -4117,7 +4191,7 @@
           </a:fontRef>
         </p:style>
         <p:txBody>
-          <a:bodyPr rtlCol="0" anchor="ctr" wrap="square"/>
+          <a:bodyPr wrap="square" rtlCol="0" anchor="ctr"/>
           <a:lstStyle/>
           <a:p>
             <a:pPr algn="ctr">
@@ -4206,7 +4280,7 @@
           </a:fontRef>
         </p:style>
         <p:txBody>
-          <a:bodyPr rtlCol="0" anchor="ctr" wrap="square"/>
+          <a:bodyPr wrap="square" rtlCol="0" anchor="ctr"/>
           <a:lstStyle/>
           <a:p>
             <a:pPr algn="ctr">
@@ -4260,7 +4334,7 @@
           </a:fontRef>
         </p:style>
         <p:txBody>
-          <a:bodyPr rtlCol="0" anchor="ctr" wrap="square"/>
+          <a:bodyPr wrap="square" rtlCol="0" anchor="ctr"/>
           <a:lstStyle/>
           <a:p>
             <a:pPr algn="ctr">
@@ -4350,7 +4424,7 @@
           </a:fontRef>
         </p:style>
         <p:txBody>
-          <a:bodyPr rtlCol="0" anchor="ctr" wrap="square"/>
+          <a:bodyPr wrap="square" rtlCol="0" anchor="ctr"/>
           <a:lstStyle/>
           <a:p>
             <a:pPr algn="ctr">
@@ -4440,7 +4514,7 @@
           </a:fontRef>
         </p:style>
         <p:txBody>
-          <a:bodyPr rtlCol="0" anchor="ctr" wrap="square"/>
+          <a:bodyPr wrap="square" rtlCol="0" anchor="ctr"/>
           <a:lstStyle/>
           <a:p>
             <a:pPr algn="ctr">
@@ -4569,7 +4643,7 @@
 </file>
 
 <file path=ppt/slides/slide4.xml><?xml version="1.0" encoding="utf-8"?>
-<p:sld xmlns:a="http://schemas.openxmlformats.org/drawingml/2006/main" xmlns:p="http://schemas.openxmlformats.org/presentationml/2006/main" xmlns:r="http://schemas.openxmlformats.org/officeDocument/2006/relationships">
+<p:sld xmlns:a="http://schemas.openxmlformats.org/drawingml/2006/main" xmlns:r="http://schemas.openxmlformats.org/officeDocument/2006/relationships" xmlns:p="http://schemas.openxmlformats.org/presentationml/2006/main">
   <p:cSld>
     <p:spTree>
       <p:nvGrpSpPr>
@@ -4577,7 +4651,14 @@
         <p:cNvGrpSpPr/>
         <p:nvPr/>
       </p:nvGrpSpPr>
-      <p:grpSpPr/>
+      <p:grpSpPr>
+        <a:xfrm>
+          <a:off x="0" y="0"/>
+          <a:ext cx="0" cy="0"/>
+          <a:chOff x="0" y="0"/>
+          <a:chExt cx="0" cy="0"/>
+        </a:xfrm>
+      </p:grpSpPr>
       <p:sp>
         <p:nvSpPr>
           <p:cNvPr id="2" name="Rectangle 1"/>
@@ -4614,7 +4695,7 @@
           </a:fontRef>
         </p:style>
         <p:txBody>
-          <a:bodyPr rtlCol="0" anchor="ctr" lIns="365760" wrap="square"/>
+          <a:bodyPr wrap="square" lIns="365760" rtlCol="0" anchor="ctr"/>
           <a:lstStyle/>
           <a:p>
             <a:pPr algn="ctr">
@@ -4649,9 +4730,27 @@
                 <a:tableStyleId>{5C22544A-7EE6-4342-B048-85BDC9FD1C3A}</a:tableStyleId>
               </a:tblPr>
               <a:tblGrid>
-                <a:gridCol w="1920240"/>
-                <a:gridCol w="3383280"/>
-                <a:gridCol w="6126480"/>
+                <a:gridCol w="1920240">
+                  <a:extLst>
+                    <a:ext uri="{9D8B030D-6E8A-4147-A177-3AD203B41FA5}">
+                      <a16:colId xmlns:a16="http://schemas.microsoft.com/office/drawing/2014/main" val="20000"/>
+                    </a:ext>
+                  </a:extLst>
+                </a:gridCol>
+                <a:gridCol w="3383280">
+                  <a:extLst>
+                    <a:ext uri="{9D8B030D-6E8A-4147-A177-3AD203B41FA5}">
+                      <a16:colId xmlns:a16="http://schemas.microsoft.com/office/drawing/2014/main" val="20001"/>
+                    </a:ext>
+                  </a:extLst>
+                </a:gridCol>
+                <a:gridCol w="6126480">
+                  <a:extLst>
+                    <a:ext uri="{9D8B030D-6E8A-4147-A177-3AD203B41FA5}">
+                      <a16:colId xmlns:a16="http://schemas.microsoft.com/office/drawing/2014/main" val="20002"/>
+                    </a:ext>
+                  </a:extLst>
+                </a:gridCol>
               </a:tblGrid>
               <a:tr h="449580">
                 <a:tc>
@@ -4723,6 +4822,11 @@
                     </a:solidFill>
                   </a:tcPr>
                 </a:tc>
+                <a:extLst>
+                  <a:ext uri="{0D108BD9-81ED-4DB2-BD59-A6C34878D82A}">
+                    <a16:rowId xmlns:a16="http://schemas.microsoft.com/office/drawing/2014/main" val="10000"/>
+                  </a:ext>
+                </a:extLst>
               </a:tr>
               <a:tr h="449580">
                 <a:tc>
@@ -4794,6 +4898,11 @@
                     </a:solidFill>
                   </a:tcPr>
                 </a:tc>
+                <a:extLst>
+                  <a:ext uri="{0D108BD9-81ED-4DB2-BD59-A6C34878D82A}">
+                    <a16:rowId xmlns:a16="http://schemas.microsoft.com/office/drawing/2014/main" val="10001"/>
+                  </a:ext>
+                </a:extLst>
               </a:tr>
               <a:tr h="449580">
                 <a:tc>
@@ -4855,6 +4964,7 @@
                         </a:defRPr>
                       </a:pPr>
                       <a:r>
+                        <a:rPr dirty="0"/>
                         <a:t>MCA / EWL / RC-Fatal / MCHECK / POST decoder DBs</a:t>
                       </a:r>
                     </a:p>
@@ -4865,6 +4975,11 @@
                     </a:solidFill>
                   </a:tcPr>
                 </a:tc>
+                <a:extLst>
+                  <a:ext uri="{0D108BD9-81ED-4DB2-BD59-A6C34878D82A}">
+                    <a16:rowId xmlns:a16="http://schemas.microsoft.com/office/drawing/2014/main" val="10002"/>
+                  </a:ext>
+                </a:extLst>
               </a:tr>
               <a:tr h="449580">
                 <a:tc>
@@ -4936,6 +5051,11 @@
                     </a:solidFill>
                   </a:tcPr>
                 </a:tc>
+                <a:extLst>
+                  <a:ext uri="{0D108BD9-81ED-4DB2-BD59-A6C34878D82A}">
+                    <a16:rowId xmlns:a16="http://schemas.microsoft.com/office/drawing/2014/main" val="10003"/>
+                  </a:ext>
+                </a:extLst>
               </a:tr>
               <a:tr h="449580">
                 <a:tc>
@@ -4997,6 +5117,7 @@
                         </a:defRPr>
                       </a:pPr>
                       <a:r>
+                        <a:rPr dirty="0"/>
                         <a:t>Wiki KB (always) + BIOS/S3M, Kernel-crash, Redfish (need-based)</a:t>
                       </a:r>
                     </a:p>
@@ -5007,6 +5128,11 @@
                     </a:solidFill>
                   </a:tcPr>
                 </a:tc>
+                <a:extLst>
+                  <a:ext uri="{0D108BD9-81ED-4DB2-BD59-A6C34878D82A}">
+                    <a16:rowId xmlns:a16="http://schemas.microsoft.com/office/drawing/2014/main" val="10004"/>
+                  </a:ext>
+                </a:extLst>
               </a:tr>
               <a:tr h="449580">
                 <a:tc>
@@ -5068,7 +5194,16 @@
                         </a:defRPr>
                       </a:pPr>
                       <a:r>
-                        <a:t>NUC PythonSV bridge — out-of-band when SUT is hung</a:t>
+                        <a:rPr dirty="0"/>
+                        <a:t>NUC </a:t>
+                      </a:r>
+                      <a:r>
+                        <a:rPr dirty="0" err="1"/>
+                        <a:t>PythonSV</a:t>
+                      </a:r>
+                      <a:r>
+                        <a:rPr dirty="0"/>
+                        <a:t> bridge — out-of-band when SUT is hung</a:t>
                       </a:r>
                     </a:p>
                   </a:txBody>
@@ -5078,6 +5213,11 @@
                     </a:solidFill>
                   </a:tcPr>
                 </a:tc>
+                <a:extLst>
+                  <a:ext uri="{0D108BD9-81ED-4DB2-BD59-A6C34878D82A}">
+                    <a16:rowId xmlns:a16="http://schemas.microsoft.com/office/drawing/2014/main" val="10005"/>
+                  </a:ext>
+                </a:extLst>
               </a:tr>
               <a:tr h="449580">
                 <a:tc>
@@ -5139,7 +5279,16 @@
                         </a:defRPr>
                       </a:pPr>
                       <a:r>
-                        <a:t>SSH-first + WinRM fallback + setup popup</a:t>
+                        <a:rPr dirty="0"/>
+                        <a:t>SSH-first + </a:t>
+                      </a:r>
+                      <a:r>
+                        <a:rPr dirty="0" err="1"/>
+                        <a:t>WinRM</a:t>
+                      </a:r>
+                      <a:r>
+                        <a:rPr dirty="0"/>
+                        <a:t> fallback + setup popup</a:t>
                       </a:r>
                     </a:p>
                   </a:txBody>
@@ -5149,6 +5298,11 @@
                     </a:solidFill>
                   </a:tcPr>
                 </a:tc>
+                <a:extLst>
+                  <a:ext uri="{0D108BD9-81ED-4DB2-BD59-A6C34878D82A}">
+                    <a16:rowId xmlns:a16="http://schemas.microsoft.com/office/drawing/2014/main" val="10006"/>
+                  </a:ext>
+                </a:extLst>
               </a:tr>
               <a:tr h="449580">
                 <a:tc>
@@ -5187,6 +5341,7 @@
                         </a:defRPr>
                       </a:pPr>
                       <a:r>
+                        <a:rPr dirty="0"/>
                         <a:t>SSH keys</a:t>
                       </a:r>
                     </a:p>
@@ -5210,6 +5365,7 @@
                         </a:defRPr>
                       </a:pPr>
                       <a:r>
+                        <a:rPr dirty="0"/>
                         <a:t>UI password, masked, never stored; user auto-normalized</a:t>
                       </a:r>
                     </a:p>
@@ -5220,6 +5376,11 @@
                     </a:solidFill>
                   </a:tcPr>
                 </a:tc>
+                <a:extLst>
+                  <a:ext uri="{0D108BD9-81ED-4DB2-BD59-A6C34878D82A}">
+                    <a16:rowId xmlns:a16="http://schemas.microsoft.com/office/drawing/2014/main" val="10007"/>
+                  </a:ext>
+                </a:extLst>
               </a:tr>
               <a:tr h="449580">
                 <a:tc>
@@ -5258,6 +5419,7 @@
                         </a:defRPr>
                       </a:pPr>
                       <a:r>
+                        <a:rPr dirty="0"/>
                         <a:t>one command</a:t>
                       </a:r>
                     </a:p>
@@ -5281,7 +5443,16 @@
                         </a:defRPr>
                       </a:pPr>
                       <a:r>
-                        <a:t>Persistent PythonSV session (imports/IPC persist)</a:t>
+                        <a:rPr dirty="0"/>
+                        <a:t>Persistent </a:t>
+                      </a:r>
+                      <a:r>
+                        <a:rPr dirty="0" err="1"/>
+                        <a:t>PythonSV</a:t>
+                      </a:r>
+                      <a:r>
+                        <a:rPr dirty="0"/>
+                        <a:t> session (imports/IPC persist)</a:t>
                       </a:r>
                     </a:p>
                   </a:txBody>
@@ -5291,6 +5462,11 @@
                     </a:solidFill>
                   </a:tcPr>
                 </a:tc>
+                <a:extLst>
+                  <a:ext uri="{0D108BD9-81ED-4DB2-BD59-A6C34878D82A}">
+                    <a16:rowId xmlns:a16="http://schemas.microsoft.com/office/drawing/2014/main" val="10008"/>
+                  </a:ext>
+                </a:extLst>
               </a:tr>
               <a:tr h="449580">
                 <a:tc>
@@ -5352,7 +5528,16 @@
                         </a:defRPr>
                       </a:pPr>
                       <a:r>
-                        <a:t>Auto-init unlock + refresh; skippable</a:t>
+                        <a:rPr dirty="0"/>
+                        <a:t>Auto-</a:t>
+                      </a:r>
+                      <a:r>
+                        <a:rPr dirty="0" err="1"/>
+                        <a:t>init</a:t>
+                      </a:r>
+                      <a:r>
+                        <a:rPr dirty="0"/>
+                        <a:t> unlock + refresh; skippable</a:t>
                       </a:r>
                     </a:p>
                   </a:txBody>
@@ -5362,6 +5547,11 @@
                     </a:solidFill>
                   </a:tcPr>
                 </a:tc>
+                <a:extLst>
+                  <a:ext uri="{0D108BD9-81ED-4DB2-BD59-A6C34878D82A}">
+                    <a16:rowId xmlns:a16="http://schemas.microsoft.com/office/drawing/2014/main" val="10009"/>
+                  </a:ext>
+                </a:extLst>
               </a:tr>
               <a:tr h="449580">
                 <a:tc>
@@ -5400,6 +5590,7 @@
                         </a:defRPr>
                       </a:pPr>
                       <a:r>
+                        <a:rPr dirty="0"/>
                         <a:t>raw dump</a:t>
                       </a:r>
                     </a:p>
@@ -5423,6 +5614,7 @@
                         </a:defRPr>
                       </a:pPr>
                       <a:r>
+                        <a:rPr dirty="0"/>
                         <a:t>Output cleaner + state interpreter notes</a:t>
                       </a:r>
                     </a:p>
@@ -5433,6 +5625,11 @@
                     </a:solidFill>
                   </a:tcPr>
                 </a:tc>
+                <a:extLst>
+                  <a:ext uri="{0D108BD9-81ED-4DB2-BD59-A6C34878D82A}">
+                    <a16:rowId xmlns:a16="http://schemas.microsoft.com/office/drawing/2014/main" val="10010"/>
+                  </a:ext>
+                </a:extLst>
               </a:tr>
               <a:tr h="449580">
                 <a:tc>
@@ -5494,6 +5691,7 @@
                         </a:defRPr>
                       </a:pPr>
                       <a:r>
+                        <a:rPr dirty="0"/>
                         <a:t>Unified smoke test (15 checks)</a:t>
                       </a:r>
                     </a:p>
@@ -5504,6 +5702,11 @@
                     </a:solidFill>
                   </a:tcPr>
                 </a:tc>
+                <a:extLst>
+                  <a:ext uri="{0D108BD9-81ED-4DB2-BD59-A6C34878D82A}">
+                    <a16:rowId xmlns:a16="http://schemas.microsoft.com/office/drawing/2014/main" val="10011"/>
+                  </a:ext>
+                </a:extLst>
               </a:tr>
             </a:tbl>
           </a:graphicData>
@@ -5518,7 +5721,7 @@
 </file>
 
 <file path=ppt/slides/slide5.xml><?xml version="1.0" encoding="utf-8"?>
-<p:sld xmlns:a="http://schemas.openxmlformats.org/drawingml/2006/main" xmlns:p="http://schemas.openxmlformats.org/presentationml/2006/main" xmlns:r="http://schemas.openxmlformats.org/officeDocument/2006/relationships">
+<p:sld xmlns:a="http://schemas.openxmlformats.org/drawingml/2006/main" xmlns:r="http://schemas.openxmlformats.org/officeDocument/2006/relationships" xmlns:p="http://schemas.openxmlformats.org/presentationml/2006/main">
   <p:cSld>
     <p:spTree>
       <p:nvGrpSpPr>
@@ -5526,7 +5729,14 @@
         <p:cNvGrpSpPr/>
         <p:nvPr/>
       </p:nvGrpSpPr>
-      <p:grpSpPr/>
+      <p:grpSpPr>
+        <a:xfrm>
+          <a:off x="0" y="0"/>
+          <a:ext cx="0" cy="0"/>
+          <a:chOff x="0" y="0"/>
+          <a:chExt cx="0" cy="0"/>
+        </a:xfrm>
+      </p:grpSpPr>
       <p:sp>
         <p:nvSpPr>
           <p:cNvPr id="2" name="Rectangle 1"/>
@@ -5563,7 +5773,7 @@
           </a:fontRef>
         </p:style>
         <p:txBody>
-          <a:bodyPr rtlCol="0" anchor="ctr" lIns="365760" wrap="square"/>
+          <a:bodyPr wrap="square" lIns="365760" rtlCol="0" anchor="ctr"/>
           <a:lstStyle/>
           <a:p>
             <a:pPr algn="ctr">
@@ -5743,7 +5953,7 @@
 </file>
 
 <file path=ppt/slides/slide6.xml><?xml version="1.0" encoding="utf-8"?>
-<p:sld xmlns:a="http://schemas.openxmlformats.org/drawingml/2006/main" xmlns:p="http://schemas.openxmlformats.org/presentationml/2006/main" xmlns:r="http://schemas.openxmlformats.org/officeDocument/2006/relationships">
+<p:sld xmlns:a="http://schemas.openxmlformats.org/drawingml/2006/main" xmlns:r="http://schemas.openxmlformats.org/officeDocument/2006/relationships" xmlns:p="http://schemas.openxmlformats.org/presentationml/2006/main">
   <p:cSld>
     <p:spTree>
       <p:nvGrpSpPr>
@@ -5751,7 +5961,14 @@
         <p:cNvGrpSpPr/>
         <p:nvPr/>
       </p:nvGrpSpPr>
-      <p:grpSpPr/>
+      <p:grpSpPr>
+        <a:xfrm>
+          <a:off x="0" y="0"/>
+          <a:ext cx="0" cy="0"/>
+          <a:chOff x="0" y="0"/>
+          <a:chExt cx="0" cy="0"/>
+        </a:xfrm>
+      </p:grpSpPr>
       <p:sp>
         <p:nvSpPr>
           <p:cNvPr id="2" name="Rectangle 1"/>
@@ -5788,7 +6005,7 @@
           </a:fontRef>
         </p:style>
         <p:txBody>
-          <a:bodyPr rtlCol="0" anchor="ctr" lIns="365760" wrap="square"/>
+          <a:bodyPr wrap="square" lIns="365760" rtlCol="0" anchor="ctr"/>
           <a:lstStyle/>
           <a:p>
             <a:pPr algn="ctr">
@@ -5837,6 +6054,7 @@
               </a:defRPr>
             </a:pPr>
             <a:r>
+              <a:rPr dirty="0"/>
               <a:t>Secrets: NUC password used only for the connection — masked in all output, never written to disk or logs.</a:t>
             </a:r>
           </a:p>
@@ -5852,6 +6070,7 @@
               </a:defRPr>
             </a:pPr>
             <a:r>
+              <a:rPr dirty="0"/>
               <a:t>Enrichment sources are OFF unless configured; failures are skipped and never block core analysis.</a:t>
             </a:r>
           </a:p>
@@ -5867,6 +6086,7 @@
               </a:defRPr>
             </a:pPr>
             <a:r>
+              <a:rPr dirty="0"/>
               <a:t>Kerberos SSO to HSDES (no token/password) for on-domain users.</a:t>
             </a:r>
           </a:p>
@@ -5882,6 +6102,7 @@
               </a:defRPr>
             </a:pPr>
             <a:r>
+              <a:rPr dirty="0"/>
               <a:t>Validated live: SSH connect + persistent session confirmed against a real 2S GNR NUC; part unlocked, 37 IPs enumerated.</a:t>
             </a:r>
           </a:p>
@@ -5897,6 +6118,7 @@
               </a:defRPr>
             </a:pPr>
             <a:r>
+              <a:rPr dirty="0"/>
               <a:t>Unified smoke test: 15 / 15 passing.</a:t>
             </a:r>
           </a:p>
@@ -5912,7 +6134,16 @@
               </a:defRPr>
             </a:pPr>
             <a:r>
-              <a:t>Published to intel-sandbox/BugScout (PR) and mirrored to the personal repo.</a:t>
+              <a:rPr dirty="0"/>
+              <a:t>Published to intel-sandbox/</a:t>
+            </a:r>
+            <a:r>
+              <a:rPr dirty="0" err="1"/>
+              <a:t>BugScout</a:t>
+            </a:r>
+            <a:r>
+              <a:rPr dirty="0"/>
+              <a:t> (PR) and mirrored to the personal repo.</a:t>
             </a:r>
           </a:p>
         </p:txBody>

</xml_diff>

<commit_message>
Fix multi-bank extraction-order bug in rca_benchmark; add strict+normalized owner accuracy metrics; investigate ownership-conflict detector gap on 22019405820; refresh benchmark and health monitor reports
</commit_message>
<xml_diff>
--- a/presentation/HSDES_NEXUS_Presentation.pptx
+++ b/presentation/HSDES_NEXUS_Presentation.pptx
@@ -3490,7 +3490,7 @@
               </a:defRPr>
             </a:pPr>
             <a:r>
-              <a:t>Phase 0 → Phase 5 · where we are and where we're going</a:t>
+              <a:t>Phase 0 → Phase 5 · current state and release gates</a:t>
             </a:r>
           </a:p>
         </p:txBody>
@@ -3584,7 +3584,7 @@
               </a:defRPr>
             </a:pPr>
             <a:r>
-              <a:t>What's New — Automation, Validation &amp; Phase 2</a:t>
+              <a:t>What's New — Operational Loop &amp; Qualification</a:t>
             </a:r>
           </a:p>
           <a:p>
@@ -3596,7 +3596,7 @@
               </a:defRPr>
             </a:pPr>
             <a:r>
-              <a:t>Shipped since the engineer-grade RCA engine</a:t>
+              <a:t>Current release baseline and remaining production gates</a:t>
             </a:r>
           </a:p>
         </p:txBody>
@@ -3694,7 +3694,7 @@
               </a:defRPr>
             </a:pPr>
             <a:r>
-              <a:t>Phase 2 AutoHSD triage — parse node from the title → SSH → collect failure-type evidence profiles → run RCA → gate → update; node-down handled gracefully.</a:t>
+              <a:t>AutoHSD closed loop — retrieve HSD → collect missing evidence with guarded SSH/BMC requirements → re-analyze → compare before/after → gate → draft/post result; 10 focused integration tests pass.</a:t>
             </a:r>
           </a:p>
           <a:p>
@@ -3709,7 +3709,22 @@
               </a:defRPr>
             </a:pPr>
             <a:r>
-              <a:t>RCA Regression Framework — golden_cases/ corpus + tools/rca_benchmark.py scoring owning-IP accuracy, precision/recall, overconfidence, false-attribution, contradiction-miss.</a:t>
+              <a:t>Release baseline — 75 tests pass, provenance covers 18/18 resources with 0 UNKNOWN, and 47 strict Golden Cases are loaded.</a:t>
+            </a:r>
+          </a:p>
+          <a:p>
+            <a:pPr>
+              <a:spcAft>
+                <a:spcPts val="700"/>
+              </a:spcAft>
+              <a:defRPr sz="1500">
+                <a:solidFill>
+                  <a:srgbClr val="1B2A4A"/>
+                </a:solidFill>
+              </a:defRPr>
+            </a:pPr>
+            <a:r>
+              <a:t>Qualification blocker — the bounded offline benchmark completes but produces 0/47 actionable predictions; live RCA measurement remains separate from fixture-only validation.</a:t>
             </a:r>
           </a:p>
         </p:txBody>
@@ -3779,7 +3794,7 @@
               </a:defRPr>
             </a:pPr>
             <a:r>
-              <a:t>Phase 2 — AutoHSD Triage Engine</a:t>
+              <a:t>Phase 2 — AutoHSD Closed-Loop Tool</a:t>
             </a:r>
           </a:p>
           <a:p>
@@ -3791,7 +3806,7 @@
               </a:defRPr>
             </a:pPr>
             <a:r>
-              <a:t>Current focus: one-liner HSD → live node triage</a:t>
+              <a:t>Implemented and fixture-tested; SSH collection remains opt-in</a:t>
             </a:r>
           </a:p>
         </p:txBody>
@@ -3923,7 +3938,7 @@
               </a:defRPr>
             </a:pPr>
             <a:r>
-              <a:t>•  Gate PASS → auto-update HSD · DRAFT → store RCA for review.</a:t>
+              <a:t>•  Gate PASS → draft HSD update; POST remains opt-in via HSDES_WRITE_ENABLED.</a:t>
             </a:r>
           </a:p>
         </p:txBody>

</xml_diff>